<commit_message>
Added lessons 2 and 3
</commit_message>
<xml_diff>
--- a/Old Notes for Reference/Lesson 03 - Inputs and Strings/Teaching Assets/Lesson 03 Inputs and Strings.pptx
+++ b/Old Notes for Reference/Lesson 03 - Inputs and Strings/Teaching Assets/Lesson 03 Inputs and Strings.pptx
@@ -264,8 +264,11 @@
     </a:lvl9pPr>
   </p:defaultTextStyle>
   <p:extLst>
+    <p:ext uri="{EFAFB233-063F-42B5-8137-9DF3F51BA10A}">
+      <p15:sldGuideLst xmlns:p15="http://schemas.microsoft.com/office/powerpoint/2012/main"/>
+    </p:ext>
     <p:ext uri="GoogleSlidesCustomDataVersion2">
-      <go:slidesCustomData xmlns:go="http://customooxmlschemas.google.com/" xmlns:ahyp="http://schemas.microsoft.com/office/drawing/2018/hyperlinkcolor" xmlns:p15="http://schemas.microsoft.com/office/powerpoint/2012/main" xmlns:p14="http://schemas.microsoft.com/office/powerpoint/2010/main" xmlns:com="http://schemas.openxmlformats.org/drawingml/2006/compatibility" xmlns:pvml="urn:schemas-microsoft-com:office:powerpoint" xmlns:v="urn:schemas-microsoft-com:vml" xmlns:o="urn:schemas-microsoft-com:office:office" xmlns:dgm="http://schemas.openxmlformats.org/drawingml/2006/diagram" xmlns:c="http://schemas.openxmlformats.org/drawingml/2006/chart" xmlns:mv="urn:schemas-microsoft-com:mac:vml" xmlns:mc="http://schemas.openxmlformats.org/markup-compatibility/2006" xmlns="" r:id="rId22" roundtripDataSignature="AMtx7mgJFyh2S5/t3gSHS2EOLNkxkGMMPw=="/>
+      <go:slidesCustomData xmlns="" xmlns:mc="http://schemas.openxmlformats.org/markup-compatibility/2006" xmlns:mv="urn:schemas-microsoft-com:mac:vml" xmlns:c="http://schemas.openxmlformats.org/drawingml/2006/chart" xmlns:dgm="http://schemas.openxmlformats.org/drawingml/2006/diagram" xmlns:o="urn:schemas-microsoft-com:office:office" xmlns:v="urn:schemas-microsoft-com:vml" xmlns:pvml="urn:schemas-microsoft-com:office:powerpoint" xmlns:com="http://schemas.openxmlformats.org/drawingml/2006/compatibility" xmlns:p14="http://schemas.microsoft.com/office/powerpoint/2010/main" xmlns:p15="http://schemas.microsoft.com/office/powerpoint/2012/main" xmlns:ahyp="http://schemas.microsoft.com/office/drawing/2018/hyperlinkcolor" xmlns:go="http://customooxmlschemas.google.com/" r:id="rId22" roundtripDataSignature="AMtx7mgJFyh2S5/t3gSHS2EOLNkxkGMMPw=="/>
     </p:ext>
   </p:extLst>
 </p:presentation>
@@ -19434,7 +19437,7 @@
               <a:buChar char="•"/>
             </a:pPr>
             <a:r>
-              <a:rPr lang="en-GB" sz="2000" b="1">
+              <a:rPr lang="en-GB" sz="2000" b="1" dirty="0">
                 <a:solidFill>
                   <a:schemeClr val="lt1"/>
                 </a:solidFill>
@@ -19445,7 +19448,7 @@
               </a:rPr>
               <a:t>We can add strings together:</a:t>
             </a:r>
-            <a:endParaRPr sz="2000">
+            <a:endParaRPr sz="2000" dirty="0">
               <a:solidFill>
                 <a:schemeClr val="lt1"/>
               </a:solidFill>
@@ -19474,7 +19477,7 @@
               <a:buNone/>
             </a:pPr>
             <a:r>
-              <a:rPr lang="en-GB" sz="1600" b="0" i="0" u="none" strike="noStrike" cap="none">
+              <a:rPr lang="en-GB" sz="1600" b="0" i="0" u="none" strike="noStrike" cap="none" dirty="0">
                 <a:solidFill>
                   <a:schemeClr val="lt1"/>
                 </a:solidFill>
@@ -19485,7 +19488,7 @@
               </a:rPr>
               <a:t>string1 = “hello”</a:t>
             </a:r>
-            <a:endParaRPr sz="1800" b="0" i="0" u="none" strike="noStrike" cap="none">
+            <a:endParaRPr sz="1800" b="0" i="0" u="none" strike="noStrike" cap="none" dirty="0">
               <a:solidFill>
                 <a:schemeClr val="lt1"/>
               </a:solidFill>
@@ -19514,7 +19517,7 @@
               <a:buNone/>
             </a:pPr>
             <a:r>
-              <a:rPr lang="en-GB" sz="1600" b="0" i="0" u="none" strike="noStrike" cap="none">
+              <a:rPr lang="en-GB" sz="1600" b="0" i="0" u="none" strike="noStrike" cap="none" dirty="0">
                 <a:solidFill>
                   <a:schemeClr val="lt1"/>
                 </a:solidFill>
@@ -19525,7 +19528,7 @@
               </a:rPr>
               <a:t>string2 = “world”</a:t>
             </a:r>
-            <a:endParaRPr sz="1800" b="0" i="0" u="none" strike="noStrike" cap="none">
+            <a:endParaRPr sz="1800" b="0" i="0" u="none" strike="noStrike" cap="none" dirty="0">
               <a:solidFill>
                 <a:schemeClr val="lt1"/>
               </a:solidFill>
@@ -19554,7 +19557,7 @@
               <a:buNone/>
             </a:pPr>
             <a:r>
-              <a:rPr lang="en-GB" sz="1600" b="0" i="0" u="none" strike="noStrike" cap="none">
+              <a:rPr lang="en-GB" sz="1600" b="0" i="0" u="none" strike="noStrike" cap="none" dirty="0">
                 <a:solidFill>
                   <a:schemeClr val="lt1"/>
                 </a:solidFill>
@@ -19565,7 +19568,7 @@
               </a:rPr>
               <a:t>string3 = string1 + “ ” + string2 </a:t>
             </a:r>
-            <a:endParaRPr sz="1800" b="0" i="0" u="none" strike="noStrike" cap="none">
+            <a:endParaRPr sz="1800" b="0" i="0" u="none" strike="noStrike" cap="none" dirty="0">
               <a:solidFill>
                 <a:schemeClr val="lt1"/>
               </a:solidFill>
@@ -19594,7 +19597,7 @@
               <a:buNone/>
             </a:pPr>
             <a:r>
-              <a:rPr lang="en-GB" sz="1600" b="0" i="0" u="none" strike="noStrike" cap="none">
+              <a:rPr lang="en-GB" sz="1600" b="0" i="0" u="none" strike="noStrike" cap="none" dirty="0">
                 <a:solidFill>
                   <a:schemeClr val="lt1"/>
                 </a:solidFill>
@@ -19605,7 +19608,7 @@
               </a:rPr>
               <a:t>print(string3)</a:t>
             </a:r>
-            <a:endParaRPr/>
+            <a:endParaRPr dirty="0"/>
           </a:p>
           <a:p>
             <a:pPr marL="228600" marR="0" lvl="0" indent="-228600" algn="l" rtl="0">
@@ -19626,7 +19629,7 @@
               <a:buChar char="•"/>
             </a:pPr>
             <a:r>
-              <a:rPr lang="en-GB" sz="1800">
+              <a:rPr lang="en-GB" sz="1800" dirty="0">
                 <a:solidFill>
                   <a:schemeClr val="lt1"/>
                 </a:solidFill>
@@ -19637,7 +19640,7 @@
               </a:rPr>
               <a:t>Output:</a:t>
             </a:r>
-            <a:endParaRPr sz="1800">
+            <a:endParaRPr sz="1800" dirty="0">
               <a:solidFill>
                 <a:schemeClr val="lt1"/>
               </a:solidFill>
@@ -19666,7 +19669,7 @@
               <a:buNone/>
             </a:pPr>
             <a:r>
-              <a:rPr lang="en-GB" sz="1800">
+              <a:rPr lang="en-GB" sz="1800" dirty="0">
                 <a:solidFill>
                   <a:schemeClr val="lt1"/>
                 </a:solidFill>
@@ -19677,7 +19680,7 @@
               </a:rPr>
               <a:t>	hello world</a:t>
             </a:r>
-            <a:endParaRPr sz="1800">
+            <a:endParaRPr sz="1800" dirty="0">
               <a:solidFill>
                 <a:schemeClr val="lt1"/>
               </a:solidFill>
@@ -19705,7 +19708,7 @@
               <a:buFont typeface="Lustria"/>
               <a:buNone/>
             </a:pPr>
-            <a:endParaRPr sz="1800" b="0" i="0" u="none" strike="noStrike" cap="none">
+            <a:endParaRPr sz="1800" b="0" i="0" u="none" strike="noStrike" cap="none" dirty="0">
               <a:solidFill>
                 <a:schemeClr val="lt1"/>
               </a:solidFill>
@@ -19757,7 +19760,7 @@
               <a:buChar char="•"/>
             </a:pPr>
             <a:r>
-              <a:rPr lang="en-GB" sz="2000" b="1">
+              <a:rPr lang="en-GB" sz="2000" b="1" dirty="0">
                 <a:solidFill>
                   <a:schemeClr val="lt1"/>
                 </a:solidFill>
@@ -19768,7 +19771,7 @@
               </a:rPr>
               <a:t>We can multiply strings</a:t>
             </a:r>
-            <a:endParaRPr/>
+            <a:endParaRPr dirty="0"/>
           </a:p>
           <a:p>
             <a:pPr marL="457200" marR="0" lvl="1" indent="0" algn="l" rtl="0">
@@ -19786,7 +19789,7 @@
               <a:buNone/>
             </a:pPr>
             <a:r>
-              <a:rPr lang="en-GB" sz="1600" b="0" i="0" u="none" strike="noStrike" cap="none">
+              <a:rPr lang="en-GB" sz="1600" b="0" i="0" u="none" strike="noStrike" cap="none" dirty="0">
                 <a:solidFill>
                   <a:schemeClr val="lt1"/>
                 </a:solidFill>
@@ -19797,7 +19800,7 @@
               </a:rPr>
               <a:t>string1 = “hello”</a:t>
             </a:r>
-            <a:endParaRPr sz="1600" b="0" i="0" u="none" strike="noStrike" cap="none">
+            <a:endParaRPr sz="1600" b="0" i="0" u="none" strike="noStrike" cap="none" dirty="0">
               <a:solidFill>
                 <a:schemeClr val="lt1"/>
               </a:solidFill>
@@ -19823,7 +19826,7 @@
               <a:buNone/>
             </a:pPr>
             <a:r>
-              <a:rPr lang="en-GB" sz="1600" b="0" i="0" u="none" strike="noStrike" cap="none">
+              <a:rPr lang="en-GB" sz="1600" b="0" i="0" u="none" strike="noStrike" cap="none" dirty="0">
                 <a:solidFill>
                   <a:schemeClr val="lt1"/>
                 </a:solidFill>
@@ -19834,7 +19837,7 @@
               </a:rPr>
               <a:t>string2 = string1 * 3</a:t>
             </a:r>
-            <a:endParaRPr sz="1600" b="0" i="0" u="none" strike="noStrike" cap="none">
+            <a:endParaRPr sz="1600" b="0" i="0" u="none" strike="noStrike" cap="none" dirty="0">
               <a:solidFill>
                 <a:schemeClr val="lt1"/>
               </a:solidFill>
@@ -19860,7 +19863,7 @@
               <a:buNone/>
             </a:pPr>
             <a:r>
-              <a:rPr lang="en-GB" sz="1600" b="0" i="0" u="none" strike="noStrike" cap="none">
+              <a:rPr lang="en-GB" sz="1600" b="0" i="0" u="none" strike="noStrike" cap="none" dirty="0">
                 <a:solidFill>
                   <a:schemeClr val="lt1"/>
                 </a:solidFill>
@@ -19871,7 +19874,7 @@
               </a:rPr>
               <a:t>print(string2)</a:t>
             </a:r>
-            <a:endParaRPr sz="1600" b="0" i="0" u="none" strike="noStrike" cap="none">
+            <a:endParaRPr sz="1600" b="0" i="0" u="none" strike="noStrike" cap="none" dirty="0">
               <a:solidFill>
                 <a:schemeClr val="lt1"/>
               </a:solidFill>
@@ -19896,7 +19899,7 @@
               <a:buFont typeface="Lustria"/>
               <a:buNone/>
             </a:pPr>
-            <a:endParaRPr sz="2000">
+            <a:endParaRPr sz="2000" dirty="0">
               <a:solidFill>
                 <a:schemeClr val="lt1"/>
               </a:solidFill>
@@ -19922,7 +19925,7 @@
               <a:buChar char="•"/>
             </a:pPr>
             <a:r>
-              <a:rPr lang="en-GB" sz="2000">
+              <a:rPr lang="en-GB" sz="2000" dirty="0">
                 <a:solidFill>
                   <a:schemeClr val="lt1"/>
                 </a:solidFill>
@@ -19933,7 +19936,7 @@
               </a:rPr>
               <a:t>Output:</a:t>
             </a:r>
-            <a:endParaRPr sz="2000">
+            <a:endParaRPr sz="2000" dirty="0">
               <a:solidFill>
                 <a:schemeClr val="lt1"/>
               </a:solidFill>
@@ -19959,7 +19962,7 @@
               <a:buNone/>
             </a:pPr>
             <a:r>
-              <a:rPr lang="en-GB" sz="2000">
+              <a:rPr lang="en-GB" sz="2000" dirty="0">
                 <a:solidFill>
                   <a:schemeClr val="lt1"/>
                 </a:solidFill>
@@ -19968,9 +19971,21 @@
                 <a:cs typeface="Lustria"/>
                 <a:sym typeface="Lustria"/>
               </a:rPr>
-              <a:t>	hellohellohello</a:t>
+              <a:t>	</a:t>
             </a:r>
-            <a:endParaRPr sz="2000">
+            <a:r>
+              <a:rPr lang="en-GB" sz="2000" dirty="0" err="1">
+                <a:solidFill>
+                  <a:schemeClr val="lt1"/>
+                </a:solidFill>
+                <a:latin typeface="Lustria"/>
+                <a:ea typeface="Lustria"/>
+                <a:cs typeface="Lustria"/>
+                <a:sym typeface="Lustria"/>
+              </a:rPr>
+              <a:t>hellohellohello</a:t>
+            </a:r>
+            <a:endParaRPr sz="2000" dirty="0">
               <a:solidFill>
                 <a:schemeClr val="lt1"/>
               </a:solidFill>
@@ -20074,7 +20089,7 @@
         <p:spPr>
           <a:xfrm>
             <a:off x="838198" y="2197085"/>
-            <a:ext cx="3473741" cy="4351338"/>
+            <a:ext cx="3473741" cy="3545989"/>
           </a:xfrm>
           <a:prstGeom prst="rect">
             <a:avLst/>
@@ -20115,7 +20130,7 @@
               <a:buChar char="●"/>
             </a:pPr>
             <a:r>
-              <a:rPr lang="en-GB" sz="2000" b="1">
+              <a:rPr lang="en-GB" sz="2000" b="1" dirty="0">
                 <a:solidFill>
                   <a:schemeClr val="lt2"/>
                 </a:solidFill>
@@ -20126,7 +20141,7 @@
               </a:rPr>
               <a:t>Make the string upper case</a:t>
             </a:r>
-            <a:endParaRPr sz="2000">
+            <a:endParaRPr sz="2000" dirty="0">
               <a:solidFill>
                 <a:schemeClr val="lt2"/>
               </a:solidFill>
@@ -20155,7 +20170,7 @@
               <a:buNone/>
             </a:pPr>
             <a:r>
-              <a:rPr lang="en-GB" sz="1600" b="0" i="0" u="none" strike="noStrike" cap="none">
+              <a:rPr lang="en-GB" sz="1600" b="0" i="0" u="none" strike="noStrike" cap="none" dirty="0" err="1">
                 <a:solidFill>
                   <a:schemeClr val="lt2"/>
                 </a:solidFill>
@@ -20164,9 +20179,21 @@
                 <a:cs typeface="Lustria"/>
                 <a:sym typeface="Lustria"/>
               </a:rPr>
-              <a:t>my_string = “hello”</a:t>
+              <a:t>my_string</a:t>
             </a:r>
-            <a:endParaRPr sz="1800" b="0" i="0" u="none" strike="noStrike" cap="none">
+            <a:r>
+              <a:rPr lang="en-GB" sz="1600" b="0" i="0" u="none" strike="noStrike" cap="none" dirty="0">
+                <a:solidFill>
+                  <a:schemeClr val="lt2"/>
+                </a:solidFill>
+                <a:latin typeface="Lustria"/>
+                <a:ea typeface="Lustria"/>
+                <a:cs typeface="Lustria"/>
+                <a:sym typeface="Lustria"/>
+              </a:rPr>
+              <a:t> = “hello”</a:t>
+            </a:r>
+            <a:endParaRPr sz="1800" b="0" i="0" u="none" strike="noStrike" cap="none" dirty="0">
               <a:solidFill>
                 <a:schemeClr val="lt2"/>
               </a:solidFill>
@@ -20195,7 +20222,7 @@
               <a:buNone/>
             </a:pPr>
             <a:r>
-              <a:rPr lang="en-GB" sz="1600" b="0" i="0" u="none" strike="noStrike" cap="none">
+              <a:rPr lang="en-GB" sz="1600" b="0" i="0" u="none" strike="noStrike" cap="none" dirty="0" err="1">
                 <a:solidFill>
                   <a:schemeClr val="lt2"/>
                 </a:solidFill>
@@ -20204,9 +20231,45 @@
                 <a:cs typeface="Lustria"/>
                 <a:sym typeface="Lustria"/>
               </a:rPr>
-              <a:t>my_string = my_string.upper()</a:t>
+              <a:t>my_string</a:t>
             </a:r>
-            <a:endParaRPr sz="1600" b="1" i="0" u="none" strike="noStrike" cap="none">
+            <a:r>
+              <a:rPr lang="en-GB" sz="1600" b="0" i="0" u="none" strike="noStrike" cap="none" dirty="0">
+                <a:solidFill>
+                  <a:schemeClr val="lt2"/>
+                </a:solidFill>
+                <a:latin typeface="Lustria"/>
+                <a:ea typeface="Lustria"/>
+                <a:cs typeface="Lustria"/>
+                <a:sym typeface="Lustria"/>
+              </a:rPr>
+              <a:t> = </a:t>
+            </a:r>
+            <a:r>
+              <a:rPr lang="en-GB" sz="1600" b="0" i="0" u="none" strike="noStrike" cap="none" dirty="0" err="1">
+                <a:solidFill>
+                  <a:schemeClr val="lt2"/>
+                </a:solidFill>
+                <a:latin typeface="Lustria"/>
+                <a:ea typeface="Lustria"/>
+                <a:cs typeface="Lustria"/>
+                <a:sym typeface="Lustria"/>
+              </a:rPr>
+              <a:t>my_string.upper</a:t>
+            </a:r>
+            <a:r>
+              <a:rPr lang="en-GB" sz="1600" b="0" i="0" u="none" strike="noStrike" cap="none" dirty="0">
+                <a:solidFill>
+                  <a:schemeClr val="lt2"/>
+                </a:solidFill>
+                <a:latin typeface="Lustria"/>
+                <a:ea typeface="Lustria"/>
+                <a:cs typeface="Lustria"/>
+                <a:sym typeface="Lustria"/>
+              </a:rPr>
+              <a:t>()</a:t>
+            </a:r>
+            <a:endParaRPr sz="1600" b="1" i="0" u="none" strike="noStrike" cap="none" dirty="0">
               <a:solidFill>
                 <a:schemeClr val="lt2"/>
               </a:solidFill>
@@ -20235,7 +20298,7 @@
               <a:buNone/>
             </a:pPr>
             <a:r>
-              <a:rPr lang="en-GB" sz="1600" b="0" i="0" u="none" strike="noStrike" cap="none">
+              <a:rPr lang="en-GB" sz="1600" b="0" i="0" u="none" strike="noStrike" cap="none" dirty="0">
                 <a:solidFill>
                   <a:schemeClr val="lt2"/>
                 </a:solidFill>
@@ -20244,9 +20307,33 @@
                 <a:cs typeface="Lustria"/>
                 <a:sym typeface="Lustria"/>
               </a:rPr>
-              <a:t>print(my_string)</a:t>
+              <a:t>print(</a:t>
             </a:r>
-            <a:endParaRPr sz="1800" b="0" i="0" u="none" strike="noStrike" cap="none">
+            <a:r>
+              <a:rPr lang="en-GB" sz="1600" b="0" i="0" u="none" strike="noStrike" cap="none" dirty="0" err="1">
+                <a:solidFill>
+                  <a:schemeClr val="lt2"/>
+                </a:solidFill>
+                <a:latin typeface="Lustria"/>
+                <a:ea typeface="Lustria"/>
+                <a:cs typeface="Lustria"/>
+                <a:sym typeface="Lustria"/>
+              </a:rPr>
+              <a:t>my_string</a:t>
+            </a:r>
+            <a:r>
+              <a:rPr lang="en-GB" sz="1600" b="0" i="0" u="none" strike="noStrike" cap="none" dirty="0">
+                <a:solidFill>
+                  <a:schemeClr val="lt2"/>
+                </a:solidFill>
+                <a:latin typeface="Lustria"/>
+                <a:ea typeface="Lustria"/>
+                <a:cs typeface="Lustria"/>
+                <a:sym typeface="Lustria"/>
+              </a:rPr>
+              <a:t>)</a:t>
+            </a:r>
+            <a:endParaRPr sz="1800" b="0" i="0" u="none" strike="noStrike" cap="none" dirty="0">
               <a:solidFill>
                 <a:schemeClr val="lt2"/>
               </a:solidFill>
@@ -20274,7 +20361,7 @@
               <a:buFont typeface="Noto Sans Symbols"/>
               <a:buNone/>
             </a:pPr>
-            <a:endParaRPr sz="1600" b="0" i="0" u="none" strike="noStrike" cap="none">
+            <a:endParaRPr sz="1600" b="0" i="0" u="none" strike="noStrike" cap="none" dirty="0">
               <a:solidFill>
                 <a:schemeClr val="lt2"/>
               </a:solidFill>
@@ -20303,7 +20390,7 @@
               <a:buChar char="●"/>
             </a:pPr>
             <a:r>
-              <a:rPr lang="en-GB" sz="1600">
+              <a:rPr lang="en-GB" sz="1600" dirty="0">
                 <a:solidFill>
                   <a:schemeClr val="lt2"/>
                 </a:solidFill>
@@ -20314,7 +20401,7 @@
               </a:rPr>
               <a:t>Output:</a:t>
             </a:r>
-            <a:endParaRPr/>
+            <a:endParaRPr dirty="0"/>
           </a:p>
           <a:p>
             <a:pPr marL="0" marR="0" lvl="0" indent="0" algn="l" rtl="0">
@@ -20335,7 +20422,7 @@
               <a:buNone/>
             </a:pPr>
             <a:r>
-              <a:rPr lang="en-GB" sz="1600">
+              <a:rPr lang="en-GB" sz="1600" dirty="0">
                 <a:solidFill>
                   <a:schemeClr val="lt2"/>
                 </a:solidFill>
@@ -20346,7 +20433,7 @@
               </a:rPr>
               <a:t>	HELLO</a:t>
             </a:r>
-            <a:endParaRPr/>
+            <a:endParaRPr dirty="0"/>
           </a:p>
           <a:p>
             <a:pPr marL="228600" marR="0" lvl="0" indent="-101600" algn="l" rtl="0">
@@ -20366,7 +20453,7 @@
               <a:buFont typeface="Noto Sans Symbols"/>
               <a:buNone/>
             </a:pPr>
-            <a:endParaRPr sz="2000">
+            <a:endParaRPr sz="2000" dirty="0">
               <a:solidFill>
                 <a:schemeClr val="lt2"/>
               </a:solidFill>
@@ -20387,7 +20474,7 @@
         <p:spPr>
           <a:xfrm>
             <a:off x="4311939" y="2197085"/>
-            <a:ext cx="3473741" cy="4351338"/>
+            <a:ext cx="3473741" cy="3545989"/>
           </a:xfrm>
           <a:prstGeom prst="rect">
             <a:avLst/>
@@ -20421,7 +20508,7 @@
               <a:buChar char="•"/>
             </a:pPr>
             <a:r>
-              <a:rPr lang="en-GB" sz="2000" b="1">
+              <a:rPr lang="en-GB" sz="2000" b="1" dirty="0">
                 <a:solidFill>
                   <a:schemeClr val="lt2"/>
                 </a:solidFill>
@@ -20432,7 +20519,7 @@
               </a:rPr>
               <a:t>Make the string lower case</a:t>
             </a:r>
-            <a:endParaRPr sz="2000" b="1">
+            <a:endParaRPr sz="2000" b="1" dirty="0">
               <a:solidFill>
                 <a:schemeClr val="lt2"/>
               </a:solidFill>
@@ -20461,7 +20548,7 @@
               <a:buNone/>
             </a:pPr>
             <a:r>
-              <a:rPr lang="en-GB" sz="1600" b="0" i="0" u="none" strike="noStrike" cap="none">
+              <a:rPr lang="en-GB" sz="1600" b="0" i="0" u="none" strike="noStrike" cap="none" dirty="0" err="1">
                 <a:solidFill>
                   <a:schemeClr val="lt2"/>
                 </a:solidFill>
@@ -20470,9 +20557,21 @@
                 <a:cs typeface="Lustria"/>
                 <a:sym typeface="Lustria"/>
               </a:rPr>
-              <a:t>my_string = “HELLO”</a:t>
+              <a:t>my_string</a:t>
             </a:r>
-            <a:endParaRPr sz="1600" b="0" i="0" u="none" strike="noStrike" cap="none">
+            <a:r>
+              <a:rPr lang="en-GB" sz="1600" b="0" i="0" u="none" strike="noStrike" cap="none" dirty="0">
+                <a:solidFill>
+                  <a:schemeClr val="lt2"/>
+                </a:solidFill>
+                <a:latin typeface="Lustria"/>
+                <a:ea typeface="Lustria"/>
+                <a:cs typeface="Lustria"/>
+                <a:sym typeface="Lustria"/>
+              </a:rPr>
+              <a:t> = “HELLO”</a:t>
+            </a:r>
+            <a:endParaRPr sz="1600" b="0" i="0" u="none" strike="noStrike" cap="none" dirty="0">
               <a:solidFill>
                 <a:schemeClr val="lt2"/>
               </a:solidFill>
@@ -20501,7 +20600,7 @@
               <a:buNone/>
             </a:pPr>
             <a:r>
-              <a:rPr lang="en-GB" sz="1600" b="0" i="0" u="none" strike="noStrike" cap="none">
+              <a:rPr lang="en-GB" sz="1600" b="0" i="0" u="none" strike="noStrike" cap="none" dirty="0" err="1">
                 <a:solidFill>
                   <a:schemeClr val="lt2"/>
                 </a:solidFill>
@@ -20510,9 +20609,45 @@
                 <a:cs typeface="Lustria"/>
                 <a:sym typeface="Lustria"/>
               </a:rPr>
-              <a:t>my_string = my_string.lower()</a:t>
+              <a:t>my_string</a:t>
             </a:r>
-            <a:endParaRPr sz="1600" b="0" i="0" u="none" strike="noStrike" cap="none">
+            <a:r>
+              <a:rPr lang="en-GB" sz="1600" b="0" i="0" u="none" strike="noStrike" cap="none" dirty="0">
+                <a:solidFill>
+                  <a:schemeClr val="lt2"/>
+                </a:solidFill>
+                <a:latin typeface="Lustria"/>
+                <a:ea typeface="Lustria"/>
+                <a:cs typeface="Lustria"/>
+                <a:sym typeface="Lustria"/>
+              </a:rPr>
+              <a:t> = </a:t>
+            </a:r>
+            <a:r>
+              <a:rPr lang="en-GB" sz="1600" b="0" i="0" u="none" strike="noStrike" cap="none" dirty="0" err="1">
+                <a:solidFill>
+                  <a:schemeClr val="lt2"/>
+                </a:solidFill>
+                <a:latin typeface="Lustria"/>
+                <a:ea typeface="Lustria"/>
+                <a:cs typeface="Lustria"/>
+                <a:sym typeface="Lustria"/>
+              </a:rPr>
+              <a:t>my_string.lower</a:t>
+            </a:r>
+            <a:r>
+              <a:rPr lang="en-GB" sz="1600" b="0" i="0" u="none" strike="noStrike" cap="none" dirty="0">
+                <a:solidFill>
+                  <a:schemeClr val="lt2"/>
+                </a:solidFill>
+                <a:latin typeface="Lustria"/>
+                <a:ea typeface="Lustria"/>
+                <a:cs typeface="Lustria"/>
+                <a:sym typeface="Lustria"/>
+              </a:rPr>
+              <a:t>()</a:t>
+            </a:r>
+            <a:endParaRPr sz="1600" b="0" i="0" u="none" strike="noStrike" cap="none" dirty="0">
               <a:solidFill>
                 <a:schemeClr val="lt2"/>
               </a:solidFill>
@@ -20541,7 +20676,7 @@
               <a:buNone/>
             </a:pPr>
             <a:r>
-              <a:rPr lang="en-GB" sz="1600" b="0" i="0" u="none" strike="noStrike" cap="none">
+              <a:rPr lang="en-GB" sz="1600" b="0" i="0" u="none" strike="noStrike" cap="none" dirty="0">
                 <a:solidFill>
                   <a:schemeClr val="lt2"/>
                 </a:solidFill>
@@ -20550,9 +20685,33 @@
                 <a:cs typeface="Lustria"/>
                 <a:sym typeface="Lustria"/>
               </a:rPr>
-              <a:t>print(my_string)</a:t>
+              <a:t>print(</a:t>
             </a:r>
-            <a:endParaRPr sz="1600" b="0" i="0" u="none" strike="noStrike" cap="none">
+            <a:r>
+              <a:rPr lang="en-GB" sz="1600" b="0" i="0" u="none" strike="noStrike" cap="none" dirty="0" err="1">
+                <a:solidFill>
+                  <a:schemeClr val="lt2"/>
+                </a:solidFill>
+                <a:latin typeface="Lustria"/>
+                <a:ea typeface="Lustria"/>
+                <a:cs typeface="Lustria"/>
+                <a:sym typeface="Lustria"/>
+              </a:rPr>
+              <a:t>my_string</a:t>
+            </a:r>
+            <a:r>
+              <a:rPr lang="en-GB" sz="1600" b="0" i="0" u="none" strike="noStrike" cap="none" dirty="0">
+                <a:solidFill>
+                  <a:schemeClr val="lt2"/>
+                </a:solidFill>
+                <a:latin typeface="Lustria"/>
+                <a:ea typeface="Lustria"/>
+                <a:cs typeface="Lustria"/>
+                <a:sym typeface="Lustria"/>
+              </a:rPr>
+              <a:t>)</a:t>
+            </a:r>
+            <a:endParaRPr sz="1600" b="0" i="0" u="none" strike="noStrike" cap="none" dirty="0">
               <a:solidFill>
                 <a:schemeClr val="lt2"/>
               </a:solidFill>
@@ -20580,7 +20739,7 @@
               <a:buFont typeface="Arial"/>
               <a:buNone/>
             </a:pPr>
-            <a:endParaRPr sz="1600" b="0" i="0" u="none" strike="noStrike" cap="none">
+            <a:endParaRPr sz="1600" b="0" i="0" u="none" strike="noStrike" cap="none" dirty="0">
               <a:solidFill>
                 <a:schemeClr val="lt2"/>
               </a:solidFill>
@@ -20608,7 +20767,7 @@
               <a:buFont typeface="Arial"/>
               <a:buNone/>
             </a:pPr>
-            <a:endParaRPr sz="1600">
+            <a:endParaRPr sz="1600" dirty="0">
               <a:solidFill>
                 <a:schemeClr val="lt2"/>
               </a:solidFill>
@@ -20637,7 +20796,7 @@
               <a:buChar char="•"/>
             </a:pPr>
             <a:r>
-              <a:rPr lang="en-GB" sz="1600">
+              <a:rPr lang="en-GB" sz="1600" dirty="0">
                 <a:solidFill>
                   <a:schemeClr val="lt2"/>
                 </a:solidFill>
@@ -20648,7 +20807,7 @@
               </a:rPr>
               <a:t>Output:</a:t>
             </a:r>
-            <a:endParaRPr sz="1600">
+            <a:endParaRPr sz="1600" dirty="0">
               <a:solidFill>
                 <a:schemeClr val="lt2"/>
               </a:solidFill>
@@ -20677,7 +20836,7 @@
               <a:buNone/>
             </a:pPr>
             <a:r>
-              <a:rPr lang="en-GB" sz="1600">
+              <a:rPr lang="en-GB" sz="1600" dirty="0">
                 <a:solidFill>
                   <a:schemeClr val="lt2"/>
                 </a:solidFill>
@@ -20688,7 +20847,7 @@
               </a:rPr>
               <a:t>	hello</a:t>
             </a:r>
-            <a:endParaRPr sz="1600">
+            <a:endParaRPr sz="1600" dirty="0">
               <a:solidFill>
                 <a:schemeClr val="lt2"/>
               </a:solidFill>
@@ -20716,7 +20875,7 @@
               <a:buFont typeface="Arial"/>
               <a:buNone/>
             </a:pPr>
-            <a:endParaRPr sz="2800">
+            <a:endParaRPr sz="2800" dirty="0">
               <a:solidFill>
                 <a:schemeClr val="dk1"/>
               </a:solidFill>
@@ -20737,7 +20896,7 @@
         <p:spPr>
           <a:xfrm>
             <a:off x="7880061" y="2185124"/>
-            <a:ext cx="4034299" cy="4351338"/>
+            <a:ext cx="4034299" cy="3092826"/>
           </a:xfrm>
           <a:prstGeom prst="rect">
             <a:avLst/>
@@ -20771,7 +20930,7 @@
               <a:buChar char="•"/>
             </a:pPr>
             <a:r>
-              <a:rPr lang="en-GB" sz="2000" b="1">
+              <a:rPr lang="en-GB" sz="2000" b="1" dirty="0">
                 <a:solidFill>
                   <a:schemeClr val="lt2"/>
                 </a:solidFill>
@@ -20782,7 +20941,7 @@
               </a:rPr>
               <a:t>Count the length of a string</a:t>
             </a:r>
-            <a:endParaRPr sz="2000" b="1">
+            <a:endParaRPr sz="2000" b="1" dirty="0">
               <a:solidFill>
                 <a:schemeClr val="lt2"/>
               </a:solidFill>
@@ -20811,7 +20970,7 @@
               <a:buNone/>
             </a:pPr>
             <a:r>
-              <a:rPr lang="en-GB" sz="1600" b="0" i="0" u="none" strike="noStrike" cap="none">
+              <a:rPr lang="en-GB" sz="1600" b="0" i="0" u="none" strike="noStrike" cap="none" dirty="0" err="1">
                 <a:solidFill>
                   <a:schemeClr val="lt2"/>
                 </a:solidFill>
@@ -20820,9 +20979,21 @@
                 <a:cs typeface="Lustria"/>
                 <a:sym typeface="Lustria"/>
               </a:rPr>
-              <a:t>my_string = “elephant”</a:t>
+              <a:t>my_string</a:t>
             </a:r>
-            <a:endParaRPr sz="1600" b="0" i="0" u="none" strike="noStrike" cap="none">
+            <a:r>
+              <a:rPr lang="en-GB" sz="1600" b="0" i="0" u="none" strike="noStrike" cap="none" dirty="0">
+                <a:solidFill>
+                  <a:schemeClr val="lt2"/>
+                </a:solidFill>
+                <a:latin typeface="Lustria"/>
+                <a:ea typeface="Lustria"/>
+                <a:cs typeface="Lustria"/>
+                <a:sym typeface="Lustria"/>
+              </a:rPr>
+              <a:t> = “elephant”</a:t>
+            </a:r>
+            <a:endParaRPr sz="1600" b="0" i="0" u="none" strike="noStrike" cap="none" dirty="0">
               <a:solidFill>
                 <a:schemeClr val="lt2"/>
               </a:solidFill>
@@ -20851,7 +21022,7 @@
               <a:buNone/>
             </a:pPr>
             <a:r>
-              <a:rPr lang="en-GB" sz="1600" b="0" i="0" u="none" strike="noStrike" cap="none">
+              <a:rPr lang="en-GB" sz="1600" b="0" i="0" u="none" strike="noStrike" cap="none" dirty="0" err="1">
                 <a:solidFill>
                   <a:schemeClr val="lt2"/>
                 </a:solidFill>
@@ -20860,9 +21031,69 @@
                 <a:cs typeface="Lustria"/>
                 <a:sym typeface="Lustria"/>
               </a:rPr>
-              <a:t>length_of_string = len(my_string)</a:t>
+              <a:t>length_of_string</a:t>
             </a:r>
-            <a:endParaRPr sz="1600" b="0" i="0" u="none" strike="noStrike" cap="none">
+            <a:r>
+              <a:rPr lang="en-GB" sz="1600" b="0" i="0" u="none" strike="noStrike" cap="none" dirty="0">
+                <a:solidFill>
+                  <a:schemeClr val="lt2"/>
+                </a:solidFill>
+                <a:latin typeface="Lustria"/>
+                <a:ea typeface="Lustria"/>
+                <a:cs typeface="Lustria"/>
+                <a:sym typeface="Lustria"/>
+              </a:rPr>
+              <a:t> = </a:t>
+            </a:r>
+            <a:r>
+              <a:rPr lang="en-GB" sz="1600" b="0" i="0" u="none" strike="noStrike" cap="none" dirty="0" err="1">
+                <a:solidFill>
+                  <a:schemeClr val="lt2"/>
+                </a:solidFill>
+                <a:latin typeface="Lustria"/>
+                <a:ea typeface="Lustria"/>
+                <a:cs typeface="Lustria"/>
+                <a:sym typeface="Lustria"/>
+              </a:rPr>
+              <a:t>len</a:t>
+            </a:r>
+            <a:r>
+              <a:rPr lang="en-GB" sz="1600" b="0" i="0" u="none" strike="noStrike" cap="none" dirty="0">
+                <a:solidFill>
+                  <a:schemeClr val="lt2"/>
+                </a:solidFill>
+                <a:latin typeface="Lustria"/>
+                <a:ea typeface="Lustria"/>
+                <a:cs typeface="Lustria"/>
+                <a:sym typeface="Lustria"/>
+              </a:rPr>
+              <a:t>(</a:t>
+            </a:r>
+            <a:r>
+              <a:rPr lang="en-GB" sz="1600" b="0" i="0" u="none" strike="noStrike" cap="none" dirty="0" err="1">
+                <a:solidFill>
+                  <a:schemeClr val="lt2"/>
+                </a:solidFill>
+                <a:latin typeface="Lustria"/>
+                <a:ea typeface="Lustria"/>
+                <a:cs typeface="Lustria"/>
+                <a:sym typeface="Lustria"/>
+              </a:rPr>
+              <a:t>my_string</a:t>
+            </a:r>
+            <a:r>
+              <a:rPr lang="en-GB" sz="1600" b="0" i="0" u="none" strike="noStrike" cap="none" dirty="0">
+                <a:solidFill>
+                  <a:schemeClr val="lt2"/>
+                </a:solidFill>
+                <a:latin typeface="Lustria"/>
+                <a:ea typeface="Lustria"/>
+                <a:cs typeface="Lustria"/>
+                <a:sym typeface="Lustria"/>
+              </a:rPr>
+              <a:t>)</a:t>
+            </a:r>
+            <a:endParaRPr sz="1600" b="0" i="0" u="none" strike="noStrike" cap="none" dirty="0">
               <a:solidFill>
                 <a:schemeClr val="lt2"/>
               </a:solidFill>
@@ -20891,7 +21122,7 @@
               <a:buNone/>
             </a:pPr>
             <a:r>
-              <a:rPr lang="en-GB" sz="1600" b="0" i="0" u="none" strike="noStrike" cap="none">
+              <a:rPr lang="en-GB" sz="1600" b="0" i="0" u="none" strike="noStrike" cap="none" dirty="0">
                 <a:solidFill>
                   <a:schemeClr val="lt2"/>
                 </a:solidFill>
@@ -20900,9 +21131,33 @@
                 <a:cs typeface="Lustria"/>
                 <a:sym typeface="Lustria"/>
               </a:rPr>
-              <a:t>print(length_of_string)</a:t>
+              <a:t>print(</a:t>
             </a:r>
-            <a:endParaRPr sz="1600" b="0" i="0" u="none" strike="noStrike" cap="none">
+            <a:r>
+              <a:rPr lang="en-GB" sz="1600" b="0" i="0" u="none" strike="noStrike" cap="none" dirty="0" err="1">
+                <a:solidFill>
+                  <a:schemeClr val="lt2"/>
+                </a:solidFill>
+                <a:latin typeface="Lustria"/>
+                <a:ea typeface="Lustria"/>
+                <a:cs typeface="Lustria"/>
+                <a:sym typeface="Lustria"/>
+              </a:rPr>
+              <a:t>length_of_string</a:t>
+            </a:r>
+            <a:r>
+              <a:rPr lang="en-GB" sz="1600" b="0" i="0" u="none" strike="noStrike" cap="none" dirty="0">
+                <a:solidFill>
+                  <a:schemeClr val="lt2"/>
+                </a:solidFill>
+                <a:latin typeface="Lustria"/>
+                <a:ea typeface="Lustria"/>
+                <a:cs typeface="Lustria"/>
+                <a:sym typeface="Lustria"/>
+              </a:rPr>
+              <a:t>)</a:t>
+            </a:r>
+            <a:endParaRPr sz="1600" b="0" i="0" u="none" strike="noStrike" cap="none" dirty="0">
               <a:solidFill>
                 <a:schemeClr val="lt2"/>
               </a:solidFill>
@@ -20930,7 +21185,7 @@
               <a:buFont typeface="Arial"/>
               <a:buNone/>
             </a:pPr>
-            <a:endParaRPr sz="1600" b="0" i="0" u="none" strike="noStrike" cap="none">
+            <a:endParaRPr sz="1600" b="0" i="0" u="none" strike="noStrike" cap="none" dirty="0">
               <a:solidFill>
                 <a:schemeClr val="lt1"/>
               </a:solidFill>
@@ -20958,7 +21213,7 @@
               <a:buFont typeface="Arial"/>
               <a:buNone/>
             </a:pPr>
-            <a:endParaRPr sz="1600">
+            <a:endParaRPr sz="1600" dirty="0">
               <a:solidFill>
                 <a:schemeClr val="lt2"/>
               </a:solidFill>
@@ -20987,7 +21242,7 @@
               <a:buChar char="•"/>
             </a:pPr>
             <a:r>
-              <a:rPr lang="en-GB" sz="1600">
+              <a:rPr lang="en-GB" sz="1600" dirty="0">
                 <a:solidFill>
                   <a:schemeClr val="lt2"/>
                 </a:solidFill>
@@ -20998,7 +21253,7 @@
               </a:rPr>
               <a:t>Output:</a:t>
             </a:r>
-            <a:endParaRPr sz="1600">
+            <a:endParaRPr sz="1600" dirty="0">
               <a:solidFill>
                 <a:schemeClr val="lt2"/>
               </a:solidFill>
@@ -21027,7 +21282,7 @@
               <a:buNone/>
             </a:pPr>
             <a:r>
-              <a:rPr lang="en-GB" sz="1600">
+              <a:rPr lang="en-GB" sz="1600" dirty="0">
                 <a:solidFill>
                   <a:schemeClr val="lt2"/>
                 </a:solidFill>
@@ -21038,7 +21293,7 @@
               </a:rPr>
               <a:t>	8</a:t>
             </a:r>
-            <a:endParaRPr sz="1600">
+            <a:endParaRPr sz="1600" dirty="0">
               <a:solidFill>
                 <a:schemeClr val="lt2"/>
               </a:solidFill>
@@ -21066,7 +21321,7 @@
               <a:buFont typeface="Arial"/>
               <a:buNone/>
             </a:pPr>
-            <a:endParaRPr sz="2800">
+            <a:endParaRPr sz="2800" dirty="0">
               <a:solidFill>
                 <a:schemeClr val="dk1"/>
               </a:solidFill>
@@ -21447,7 +21702,7 @@
               <a:buNone/>
             </a:pPr>
             <a:r>
-              <a:rPr lang="en-GB" sz="2523" b="1">
+              <a:rPr lang="en-GB" sz="2523" b="1" dirty="0">
                 <a:solidFill>
                   <a:schemeClr val="lt2"/>
                 </a:solidFill>
@@ -21459,7 +21714,7 @@
               <a:t>Concatenation</a:t>
             </a:r>
             <a:r>
-              <a:rPr lang="en-GB" sz="1740">
+              <a:rPr lang="en-GB" sz="1740" dirty="0">
                 <a:solidFill>
                   <a:schemeClr val="lt2"/>
                 </a:solidFill>
@@ -21471,7 +21726,7 @@
               <a:t> </a:t>
             </a:r>
             <a:r>
-              <a:rPr lang="en-GB" sz="2436">
+              <a:rPr lang="en-GB" sz="2436" dirty="0">
                 <a:solidFill>
                   <a:schemeClr val="lt2"/>
                 </a:solidFill>
@@ -21482,7 +21737,7 @@
               </a:rPr>
               <a:t>(adding strings together)</a:t>
             </a:r>
-            <a:endParaRPr sz="1740">
+            <a:endParaRPr sz="1740" dirty="0">
               <a:solidFill>
                 <a:schemeClr val="lt2"/>
               </a:solidFill>
@@ -21507,7 +21762,7 @@
               <a:buNone/>
             </a:pPr>
             <a:r>
-              <a:rPr lang="en-GB" sz="1740">
+              <a:rPr lang="en-GB" sz="1740" dirty="0">
                 <a:solidFill>
                   <a:schemeClr val="lt2"/>
                 </a:solidFill>
@@ -21518,7 +21773,7 @@
               </a:rPr>
               <a:t>name = “Alan”</a:t>
             </a:r>
-            <a:endParaRPr/>
+            <a:endParaRPr dirty="0"/>
           </a:p>
           <a:p>
             <a:pPr marL="0" lvl="0" indent="0" algn="l" rtl="0">
@@ -21535,7 +21790,7 @@
               <a:buNone/>
             </a:pPr>
             <a:r>
-              <a:rPr lang="en-GB" sz="1740">
+              <a:rPr lang="en-GB" sz="1740" dirty="0">
                 <a:solidFill>
                   <a:schemeClr val="lt2"/>
                 </a:solidFill>
@@ -21546,7 +21801,7 @@
               </a:rPr>
               <a:t>age = 31</a:t>
             </a:r>
-            <a:endParaRPr/>
+            <a:endParaRPr dirty="0"/>
           </a:p>
           <a:p>
             <a:pPr marL="0" lvl="0" indent="0" algn="l" rtl="0">
@@ -21563,7 +21818,7 @@
               <a:buNone/>
             </a:pPr>
             <a:r>
-              <a:rPr lang="en-GB" sz="1740">
+              <a:rPr lang="en-GB" sz="1740" dirty="0">
                 <a:solidFill>
                   <a:schemeClr val="lt2"/>
                 </a:solidFill>
@@ -21574,7 +21829,7 @@
               </a:rPr>
               <a:t>output = “Hello ” + name + “ you are + str(age) + “ years old.”</a:t>
             </a:r>
-            <a:endParaRPr/>
+            <a:endParaRPr dirty="0"/>
           </a:p>
           <a:p>
             <a:pPr marL="0" lvl="0" indent="0" algn="l" rtl="0">
@@ -21591,7 +21846,7 @@
               <a:buNone/>
             </a:pPr>
             <a:r>
-              <a:rPr lang="en-GB" sz="1740">
+              <a:rPr lang="en-GB" sz="1740" dirty="0">
                 <a:solidFill>
                   <a:schemeClr val="lt2"/>
                 </a:solidFill>
@@ -21602,7 +21857,7 @@
               </a:rPr>
               <a:t>print(output)</a:t>
             </a:r>
-            <a:endParaRPr/>
+            <a:endParaRPr dirty="0"/>
           </a:p>
           <a:p>
             <a:pPr marL="0" lvl="0" indent="0" algn="l" rtl="0">
@@ -21619,7 +21874,7 @@
               <a:buNone/>
             </a:pPr>
             <a:r>
-              <a:rPr lang="en-GB" sz="1740">
+              <a:rPr lang="en-GB" sz="1740" dirty="0">
                 <a:solidFill>
                   <a:schemeClr val="lt2"/>
                 </a:solidFill>
@@ -21630,7 +21885,7 @@
               </a:rPr>
               <a:t>Output:</a:t>
             </a:r>
-            <a:endParaRPr/>
+            <a:endParaRPr dirty="0"/>
           </a:p>
           <a:p>
             <a:pPr marL="0" lvl="0" indent="0" algn="l" rtl="0">
@@ -21647,7 +21902,7 @@
               <a:buNone/>
             </a:pPr>
             <a:r>
-              <a:rPr lang="en-GB" sz="1740">
+              <a:rPr lang="en-GB" sz="1740" dirty="0">
                 <a:solidFill>
                   <a:schemeClr val="lt2"/>
                 </a:solidFill>
@@ -21658,7 +21913,7 @@
               </a:rPr>
               <a:t>Hello Alan you are 31 years old.</a:t>
             </a:r>
-            <a:endParaRPr/>
+            <a:endParaRPr dirty="0"/>
           </a:p>
         </p:txBody>
       </p:sp>
@@ -24613,7 +24868,7 @@
                 <a:buNone/>
               </a:pPr>
               <a:r>
-                <a:rPr lang="en-GB" sz="2700">
+                <a:rPr lang="en-GB" sz="2700" dirty="0">
                   <a:solidFill>
                     <a:schemeClr val="lt1"/>
                   </a:solidFill>
@@ -24624,7 +24879,7 @@
                 </a:rPr>
                 <a:t>Up until now, we have been doing calculations using variables that have been “hard coded”.</a:t>
               </a:r>
-              <a:endParaRPr sz="2700">
+              <a:endParaRPr sz="2700" dirty="0">
                 <a:solidFill>
                   <a:schemeClr val="lt1"/>
                 </a:solidFill>

</xml_diff>